<commit_message>
final review & check of thesis ready for final feedback, additional updates to powerpoint presentation
</commit_message>
<xml_diff>
--- a/docs/SPB_Presentation_AlexMartin.pptx
+++ b/docs/SPB_Presentation_AlexMartin.pptx
@@ -1366,8 +1366,12 @@
           </a:p>
           <a:p>
             <a:r>
+              <a:rPr lang="en-AU" b="1" dirty="0"/>
+              <a:t>The estimate gives 22.3 per cent lower hazard per additional rest day. Lewis [4] reported a 15.96 per cent reduction</a:t>
+            </a:r>
+            <a:r>
               <a:rPr b="1" dirty="0"/>
-              <a:t>Days rest implies 22.3 per cent lower hazard per extra</a:t>
+              <a:t>, on different seasons with a different model</a:t>
             </a:r>
             <a:r>
               <a:rPr lang="en-AU" b="1" dirty="0"/>
@@ -1375,30 +1379,18 @@
             </a:r>
             <a:r>
               <a:rPr b="1" dirty="0"/>
-              <a:t>rest day against Lewis at 15.96 per cent, on different seasons with a different model</a:t>
-            </a:r>
+              <a:t>and outcome definition. </a:t>
+            </a:r>
+            <a:endParaRPr lang="en-AU" b="1" dirty="0"/>
+          </a:p>
+          <a:p>
             <a:r>
               <a:rPr lang="en-AU" b="1" dirty="0"/>
-              <a:t> </a:t>
-            </a:r>
-            <a:r>
-              <a:rPr b="1" dirty="0"/>
-              <a:t>and outcome definition. </a:t>
-            </a:r>
-            <a:endParaRPr lang="en-AU" b="1" dirty="0"/>
-          </a:p>
-          <a:p>
-            <a:r>
-              <a:rPr b="1" dirty="0"/>
-              <a:t>That is </a:t>
-            </a:r>
-            <a:r>
-              <a:rPr lang="en-AU" b="1" dirty="0"/>
-              <a:t>not replication but more agreeing on the effect.</a:t>
-            </a:r>
-          </a:p>
-          <a:p>
-            <a:endParaRPr lang="en-AU" b="1" dirty="0"/>
+              <a:t>That is not replication, but the two do agree on the direction of the effect.</a:t>
+            </a:r>
+          </a:p>
+          <a:p>
+            <a:endParaRPr lang="en-AU" u="sng" dirty="0"/>
           </a:p>
           <a:p>
             <a:r>
@@ -4380,7 +4372,7 @@
           <a:p>
             <a:fld id="{A80F0AFE-CC19-9F41-8D4C-4453224975D5}" type="datetime1">
               <a:rPr lang="en-AU" smtClean="0"/>
-              <a:t>7/9/2026</a:t>
+              <a:t>12/9/2026</a:t>
             </a:fld>
             <a:endParaRPr lang="en-US"/>
           </a:p>
@@ -4671,7 +4663,7 @@
           <a:p>
             <a:fld id="{FA056906-5A5C-304C-8512-E66F74D33241}" type="datetime1">
               <a:rPr lang="en-AU" smtClean="0"/>
-              <a:t>7/9/2026</a:t>
+              <a:t>12/9/2026</a:t>
             </a:fld>
             <a:endParaRPr lang="en-US"/>
           </a:p>
@@ -4849,7 +4841,7 @@
           <a:p>
             <a:fld id="{9137B1CD-6349-074C-8626-AD07E42E1CDD}" type="datetime1">
               <a:rPr lang="en-AU" smtClean="0"/>
-              <a:t>7/9/2026</a:t>
+              <a:t>12/9/2026</a:t>
             </a:fld>
             <a:endParaRPr lang="en-US"/>
           </a:p>
@@ -5017,7 +5009,7 @@
           <a:p>
             <a:fld id="{E7C48768-7800-9B48-8032-02FFEDA20D22}" type="datetime1">
               <a:rPr lang="en-AU" smtClean="0"/>
-              <a:t>7/9/2026</a:t>
+              <a:t>12/9/2026</a:t>
             </a:fld>
             <a:endParaRPr lang="en-US"/>
           </a:p>
@@ -5262,7 +5254,7 @@
           <a:p>
             <a:fld id="{23F9E3A6-BFB2-D947-8035-DA7D5A6D3FCF}" type="datetime1">
               <a:rPr lang="en-AU" smtClean="0"/>
-              <a:t>7/9/2026</a:t>
+              <a:t>12/9/2026</a:t>
             </a:fld>
             <a:endParaRPr lang="en-US"/>
           </a:p>
@@ -5547,7 +5539,7 @@
           <a:p>
             <a:fld id="{05DCA834-9FDD-5A4D-A53B-C1C355E4801B}" type="datetime1">
               <a:rPr lang="en-AU" smtClean="0"/>
-              <a:t>7/9/2026</a:t>
+              <a:t>12/9/2026</a:t>
             </a:fld>
             <a:endParaRPr lang="en-US"/>
           </a:p>
@@ -5966,7 +5958,7 @@
           <a:p>
             <a:fld id="{742CFFEA-49B0-6440-AB44-F6D61AC4E3CC}" type="datetime1">
               <a:rPr lang="en-AU" smtClean="0"/>
-              <a:t>7/9/2026</a:t>
+              <a:t>12/9/2026</a:t>
             </a:fld>
             <a:endParaRPr lang="en-US"/>
           </a:p>
@@ -6083,7 +6075,7 @@
           <a:p>
             <a:fld id="{CD8590F6-1921-C840-955D-8E25AED5C2C3}" type="datetime1">
               <a:rPr lang="en-AU" smtClean="0"/>
-              <a:t>7/9/2026</a:t>
+              <a:t>12/9/2026</a:t>
             </a:fld>
             <a:endParaRPr lang="en-US"/>
           </a:p>
@@ -6178,7 +6170,7 @@
           <a:p>
             <a:fld id="{997088E0-259B-6E4D-A718-E281BD79F598}" type="datetime1">
               <a:rPr lang="en-AU" smtClean="0"/>
-              <a:t>7/9/2026</a:t>
+              <a:t>12/9/2026</a:t>
             </a:fld>
             <a:endParaRPr lang="en-US"/>
           </a:p>
@@ -6576,7 +6568,7 @@
           <a:p>
             <a:fld id="{F890593A-F4BA-F845-B2D0-50823751545E}" type="datetime1">
               <a:rPr lang="en-AU" smtClean="0"/>
-              <a:t>7/9/2026</a:t>
+              <a:t>12/9/2026</a:t>
             </a:fld>
             <a:endParaRPr lang="en-US"/>
           </a:p>
@@ -6828,7 +6820,7 @@
           <a:p>
             <a:fld id="{F9162369-36DE-234A-96B5-CE00A698ECDF}" type="datetime1">
               <a:rPr lang="en-AU" smtClean="0"/>
-              <a:t>7/9/2026</a:t>
+              <a:t>12/9/2026</a:t>
             </a:fld>
             <a:endParaRPr lang="en-US"/>
           </a:p>
@@ -7039,7 +7031,7 @@
           <a:p>
             <a:fld id="{2F00B482-33AF-0841-9A67-517C02212B0D}" type="datetime1">
               <a:rPr lang="en-AU" smtClean="0"/>
-              <a:t>7/9/2026</a:t>
+              <a:t>12/9/2026</a:t>
             </a:fld>
             <a:endParaRPr lang="en-US"/>
           </a:p>
@@ -17170,7 +17162,7 @@
         <p:spPr>
           <a:xfrm>
             <a:off x="8253599" y="4898888"/>
-            <a:ext cx="2560320" cy="492443"/>
+            <a:ext cx="2560320" cy="738664"/>
           </a:xfrm>
           <a:prstGeom prst="rect">
             <a:avLst/>
@@ -17190,7 +17182,7 @@
             </a:pPr>
             <a:r>
               <a:rPr lang="en-AU" sz="1600" b="1" dirty="0"/>
-              <a:t>81.4% reinjured within a season</a:t>
+              <a:t>81.4% reinjured within the same or following season </a:t>
             </a:r>
             <a:r>
               <a:rPr lang="en-AU" sz="1600" dirty="0"/>
@@ -19503,7 +19495,7 @@
                 </a:solidFill>
                 <a:latin typeface="Calibri"/>
               </a:rPr>
-              <a:t>, Overuse Pathology, Acute noncontact, Acute Contact)</a:t>
+              <a:t>, Overuse Pathology, Acute noncontact, Acute Impact)</a:t>
             </a:r>
             <a:endParaRPr lang="en-AU" sz="1300" b="0" i="1" dirty="0">
               <a:solidFill>

</xml_diff>